<commit_message>
Decks: one-by-one Italian reveals, Italian under game rules/steps, alternating Describe-it, unit 1 audio; 1A-1 linked for today's trial
Co-Authored-By: Claude Opus 5.5 <noreply@anthropic.com>
Claude-Session: https://claude.ai/code/session_01WMhLn9wqKhsSQGNMWzVMPf
</commit_message>
<xml_diff>
--- a/materials/B1/B1_8A-2_The_right_job_for_you.pptx
+++ b/materials/B1/B1_8A-2_The_right_job_for_you.pptx
@@ -1857,7 +1857,7 @@
             <a:r>
               <a:rPr lang="en-US" dirty="0"/>
               <a:t>5. Vocabulary · in Italian (2 min)
-CONSOLIDATION for slower students (2 min). Class says the Italian aloud for each word, then ONE click shows all the Italian and the warning. Spend 20 seconds on the traps: 'a share' (noun) = una quota; 'pitch' has many meanings (football pitch, a pitch = presentation); 'succedere' is NOT 'succeed' – it means 'happen'. Quick CCQ: 'The Dragons take 25% of the profits – is that a share?' (yes).</a:t>
+CONSOLIDATION for slower students (2 min). Class says the Italian aloud for each word, then click once per word to show its Italian and the warning. Spend 20 seconds on the traps: 'a share' (noun) = una quota; 'pitch' has many meanings (football pitch, a pitch = presentation); 'succedere' is NOT 'succeed' – it means 'happen'. Quick CCQ: 'The Dragons take 25% of the profits – is that a share?' (yes).</a:t>
             </a:r>
             <a:endParaRPr lang="en-US" dirty="0"/>
           </a:p>
@@ -2965,6 +2965,9 @@
           </a:p>
           <a:p>
             <a:pPr indent="0" marL="0">
+              <a:spcBef>
+                <a:spcPts val="500"/>
+              </a:spcBef>
               <a:spcAft>
                 <a:spcPts val="200"/>
               </a:spcAft>
@@ -2985,6 +2988,9 @@
           </a:p>
           <a:p>
             <a:pPr indent="0" marL="0">
+              <a:spcBef>
+                <a:spcPts val="500"/>
+              </a:spcBef>
               <a:spcAft>
                 <a:spcPts val="200"/>
               </a:spcAft>
@@ -3005,6 +3011,9 @@
           </a:p>
           <a:p>
             <a:pPr indent="0" marL="0">
+              <a:spcBef>
+                <a:spcPts val="500"/>
+              </a:spcBef>
               <a:spcAft>
                 <a:spcPts val="200"/>
               </a:spcAft>
@@ -3888,11 +3897,11 @@
         <p:spPr>
           <a:xfrm>
             <a:off x="320040" y="1417320"/>
-            <a:ext cx="2697480" cy="2057400"/>
+            <a:ext cx="2697480" cy="2194560"/>
           </a:xfrm>
           <a:prstGeom prst="roundRect">
             <a:avLst>
-              <a:gd name="adj" fmla="val 6222"/>
+              <a:gd name="adj" fmla="val 5833"/>
             </a:avLst>
           </a:prstGeom>
           <a:solidFill>
@@ -3974,7 +3983,7 @@
               <a:buNone/>
             </a:pPr>
             <a:r>
-              <a:rPr lang="en-US" sz="1500" dirty="0">
+              <a:rPr lang="en-US" sz="1400" dirty="0">
                 <a:solidFill>
                   <a:srgbClr val="1B2559"/>
                 </a:solidFill>
@@ -3984,7 +3993,7 @@
               </a:rPr>
               <a:t>How to play</a:t>
             </a:r>
-            <a:endParaRPr lang="en-US" sz="1500" dirty="0"/>
+            <a:endParaRPr lang="en-US" sz="1400" dirty="0"/>
           </a:p>
         </p:txBody>
       </p:sp>
@@ -3997,7 +4006,7 @@
         <p:spPr>
           <a:xfrm>
             <a:off x="886968" y="1892808"/>
-            <a:ext cx="2039112" cy="1508760"/>
+            <a:ext cx="2039112" cy="1645920"/>
           </a:xfrm>
           <a:prstGeom prst="rect">
             <a:avLst/>
@@ -4011,16 +4020,15 @@
           </a:bodyPr>
           <a:lstStyle/>
           <a:p>
-            <a:pPr marL="177800" indent="-177800">
+            <a:pPr marL="190500" indent="-190500">
               <a:spcAft>
                 <a:spcPts val="200"/>
               </a:spcAft>
               <a:buSzPct val="100000"/>
-              <a:buFont typeface="+mj-lt"/>
-              <a:buAutoNum type="arabicPeriod" startAt="1"/>
-            </a:pPr>
-            <a:r>
-              <a:rPr lang="en-US" sz="1150" dirty="0">
+              <a:buChar char="1"/>
+            </a:pPr>
+            <a:r>
+              <a:rPr lang="en-US" sz="900" dirty="0">
                 <a:solidFill>
                   <a:srgbClr val="1B2559"/>
                 </a:solidFill>
@@ -4030,41 +4038,42 @@
               </a:rPr>
               <a:t>Teams: bet INVEST or I'M OUT for each product.</a:t>
             </a:r>
-            <a:endParaRPr lang="en-US" sz="1150" dirty="0"/>
-          </a:p>
-          <a:p>
-            <a:pPr marL="177800" indent="-177800">
+            <a:endParaRPr lang="en-US" sz="900" dirty="0"/>
+          </a:p>
+          <a:p>
+            <a:pPr marL="190500" indent="-190500">
               <a:spcAft>
                 <a:spcPts val="200"/>
               </a:spcAft>
               <a:buSzPct val="100000"/>
-              <a:buFont typeface="+mj-lt"/>
-              <a:buAutoNum type="arabicPeriod" startAt="1"/>
-            </a:pPr>
-            <a:r>
-              <a:rPr lang="en-US" sz="1150" dirty="0">
-                <a:solidFill>
-                  <a:srgbClr val="1B2559"/>
+              <a:buChar char="​"/>
+            </a:pPr>
+            <a:r>
+              <a:rPr lang="en-US" sz="800" i="1" dirty="0">
+                <a:solidFill>
+                  <a:srgbClr val="5B6785"/>
                 </a:solidFill>
                 <a:latin typeface="Segoe UI" pitchFamily="34" charset="0"/>
                 <a:ea typeface="Segoe UI" pitchFamily="34" charset="-122"/>
                 <a:cs typeface="Segoe UI" pitchFamily="34" charset="-120"/>
               </a:rPr>
-              <a:t>Groups of 3: read A p.109, B p.113, C p.114. Tell the others.</a:t>
-            </a:r>
-            <a:endParaRPr lang="en-US" sz="1150" dirty="0"/>
-          </a:p>
-          <a:p>
-            <a:pPr marL="177800" indent="-177800">
+              <a:t>Squadre: scommettete INVESTE o FUORI.</a:t>
+            </a:r>
+            <a:endParaRPr lang="en-US" sz="900" dirty="0"/>
+          </a:p>
+          <a:p>
+            <a:pPr marL="190500" indent="-190500">
+              <a:spcBef>
+                <a:spcPts val="500"/>
+              </a:spcBef>
               <a:spcAft>
                 <a:spcPts val="200"/>
               </a:spcAft>
               <a:buSzPct val="100000"/>
-              <a:buFont typeface="+mj-lt"/>
-              <a:buAutoNum type="arabicPeriod" startAt="1"/>
-            </a:pPr>
-            <a:r>
-              <a:rPr lang="en-US" sz="1150" dirty="0">
+              <a:buChar char="2"/>
+            </a:pPr>
+            <a:r>
+              <a:rPr lang="en-US" sz="900" dirty="0">
                 <a:solidFill>
                   <a:srgbClr val="1B2559"/>
                 </a:solidFill>
@@ -4072,9 +4081,75 @@
                 <a:ea typeface="Segoe UI" pitchFamily="34" charset="-122"/>
                 <a:cs typeface="Segoe UI" pitchFamily="34" charset="-120"/>
               </a:rPr>
+              <a:t>Groups of 3: read A p.109, B p.113, C p.114. Tell the others.</a:t>
+            </a:r>
+            <a:endParaRPr lang="en-US" sz="900" dirty="0"/>
+          </a:p>
+          <a:p>
+            <a:pPr marL="190500" indent="-190500">
+              <a:spcAft>
+                <a:spcPts val="200"/>
+              </a:spcAft>
+              <a:buSzPct val="100000"/>
+              <a:buChar char="​"/>
+            </a:pPr>
+            <a:r>
+              <a:rPr lang="en-US" sz="800" i="1" dirty="0">
+                <a:solidFill>
+                  <a:srgbClr val="5B6785"/>
+                </a:solidFill>
+                <a:latin typeface="Segoe UI" pitchFamily="34" charset="0"/>
+                <a:ea typeface="Segoe UI" pitchFamily="34" charset="-122"/>
+                <a:cs typeface="Segoe UI" pitchFamily="34" charset="-120"/>
+              </a:rPr>
+              <a:t>Gruppi da 3: leggete A, B, C e raccontate.</a:t>
+            </a:r>
+            <a:endParaRPr lang="en-US" sz="900" dirty="0"/>
+          </a:p>
+          <a:p>
+            <a:pPr marL="190500" indent="-190500">
+              <a:spcBef>
+                <a:spcPts val="500"/>
+              </a:spcBef>
+              <a:spcAft>
+                <a:spcPts val="200"/>
+              </a:spcAft>
+              <a:buSzPct val="100000"/>
+              <a:buChar char="3"/>
+            </a:pPr>
+            <a:r>
+              <a:rPr lang="en-US" sz="900" dirty="0">
+                <a:solidFill>
+                  <a:srgbClr val="1B2559"/>
+                </a:solidFill>
+                <a:latin typeface="Segoe UI" pitchFamily="34" charset="0"/>
+                <a:ea typeface="Segoe UI" pitchFamily="34" charset="-122"/>
+                <a:cs typeface="Segoe UI" pitchFamily="34" charset="-120"/>
+              </a:rPr>
               <a:t>Right bet = 1 point.</a:t>
             </a:r>
-            <a:endParaRPr lang="en-US" sz="1150" dirty="0"/>
+            <a:endParaRPr lang="en-US" sz="900" dirty="0"/>
+          </a:p>
+          <a:p>
+            <a:pPr marL="190500" indent="-190500">
+              <a:spcAft>
+                <a:spcPts val="200"/>
+              </a:spcAft>
+              <a:buSzPct val="100000"/>
+              <a:buChar char="​"/>
+            </a:pPr>
+            <a:r>
+              <a:rPr lang="en-US" sz="800" i="1" dirty="0">
+                <a:solidFill>
+                  <a:srgbClr val="5B6785"/>
+                </a:solidFill>
+                <a:latin typeface="Segoe UI" pitchFamily="34" charset="0"/>
+                <a:ea typeface="Segoe UI" pitchFamily="34" charset="-122"/>
+                <a:cs typeface="Segoe UI" pitchFamily="34" charset="-120"/>
+              </a:rPr>
+              <a:t>Scommessa giusta = 1 punto.</a:t>
+            </a:r>
+            <a:endParaRPr lang="en-US" sz="900" dirty="0"/>
           </a:p>
         </p:txBody>
       </p:sp>
@@ -8103,7 +8178,7 @@
               <a:buChar char="•"/>
             </a:pPr>
             <a:r>
-              <a:rPr lang="en-US" sz="1100" dirty="0">
+              <a:rPr lang="en-US" sz="700" dirty="0">
                 <a:solidFill>
                   <a:srgbClr val="1B2559"/>
                 </a:solidFill>
@@ -8113,7 +8188,7 @@
               </a:rPr>
               <a:t>Listen once: what was different for Joe and Jake?</a:t>
             </a:r>
-            <a:endParaRPr lang="en-US" sz="1100" dirty="0"/>
+            <a:endParaRPr lang="en-US" sz="700" dirty="0"/>
           </a:p>
           <a:p>
             <a:pPr marL="152400" indent="-152400">
@@ -8121,20 +8196,65 @@
                 <a:spcPts val="200"/>
               </a:spcAft>
               <a:buSzPct val="100000"/>
-              <a:buChar char="•"/>
-            </a:pPr>
-            <a:r>
-              <a:rPr lang="en-US" sz="1100" dirty="0">
-                <a:solidFill>
-                  <a:srgbClr val="1B2559"/>
+              <a:buChar char="​"/>
+            </a:pPr>
+            <a:r>
+              <a:rPr lang="en-US" sz="700" i="1" dirty="0">
+                <a:solidFill>
+                  <a:srgbClr val="5B6785"/>
                 </a:solidFill>
                 <a:latin typeface="Segoe UI" pitchFamily="34" charset="0"/>
                 <a:ea typeface="Segoe UI" pitchFamily="34" charset="-122"/>
                 <a:cs typeface="Segoe UI" pitchFamily="34" charset="-120"/>
               </a:rPr>
+              <a:t>Ascolta: cosa c'è stato di diverso per Joe e Jake?</a:t>
+            </a:r>
+            <a:endParaRPr lang="en-US" sz="700" dirty="0"/>
+          </a:p>
+          <a:p>
+            <a:pPr marL="152400" indent="-152400">
+              <a:spcBef>
+                <a:spcPts val="500"/>
+              </a:spcBef>
+              <a:spcAft>
+                <a:spcPts val="200"/>
+              </a:spcAft>
+              <a:buSzPct val="100000"/>
+              <a:buChar char="•"/>
+            </a:pPr>
+            <a:r>
+              <a:rPr lang="en-US" sz="700" dirty="0">
+                <a:solidFill>
+                  <a:srgbClr val="1B2559"/>
+                </a:solidFill>
+                <a:latin typeface="Segoe UI" pitchFamily="34" charset="0"/>
+                <a:ea typeface="Segoe UI" pitchFamily="34" charset="-122"/>
+                <a:cs typeface="Segoe UI" pitchFamily="34" charset="-120"/>
+              </a:rPr>
               <a:t>Listen again. Make notes about 1–6.</a:t>
             </a:r>
-            <a:endParaRPr lang="en-US" sz="1100" dirty="0"/>
+            <a:endParaRPr lang="en-US" sz="700" dirty="0"/>
+          </a:p>
+          <a:p>
+            <a:pPr marL="152400" indent="-152400">
+              <a:spcAft>
+                <a:spcPts val="200"/>
+              </a:spcAft>
+              <a:buSzPct val="100000"/>
+              <a:buChar char="​"/>
+            </a:pPr>
+            <a:r>
+              <a:rPr lang="en-US" sz="700" i="1" dirty="0">
+                <a:solidFill>
+                  <a:srgbClr val="5B6785"/>
+                </a:solidFill>
+                <a:latin typeface="Segoe UI" pitchFamily="34" charset="0"/>
+                <a:ea typeface="Segoe UI" pitchFamily="34" charset="-122"/>
+                <a:cs typeface="Segoe UI" pitchFamily="34" charset="-120"/>
+              </a:rPr>
+              <a:t>Riascolta. Prendi appunti su 1–6.</a:t>
+            </a:r>
+            <a:endParaRPr lang="en-US" sz="700" dirty="0"/>
           </a:p>
         </p:txBody>
       </p:sp>
@@ -11411,6 +11531,9 @@
           </a:p>
           <a:p>
             <a:pPr marL="152400" indent="-152400">
+              <a:spcBef>
+                <a:spcPts val="500"/>
+              </a:spcBef>
               <a:spcAft>
                 <a:spcPts val="200"/>
               </a:spcAft>
@@ -11432,6 +11555,9 @@
           </a:p>
           <a:p>
             <a:pPr marL="152400" indent="-152400">
+              <a:spcBef>
+                <a:spcPts val="500"/>
+              </a:spcBef>
               <a:spcAft>
                 <a:spcPts val="200"/>
               </a:spcAft>
@@ -11453,6 +11579,9 @@
           </a:p>
           <a:p>
             <a:pPr marL="152400" indent="-152400">
+              <a:spcBef>
+                <a:spcPts val="500"/>
+              </a:spcBef>
               <a:spcAft>
                 <a:spcPts val="200"/>
               </a:spcAft>
@@ -16190,7 +16319,7 @@
               <a:buChar char="•"/>
             </a:pPr>
             <a:r>
-              <a:rPr lang="en-US" sz="900" dirty="0">
+              <a:rPr lang="en-US" sz="800" dirty="0">
                 <a:solidFill>
                   <a:srgbClr val="1B2559"/>
                 </a:solidFill>
@@ -16200,10 +16329,13 @@
               </a:rPr>
               <a:t>an app · a drink · a gadget…</a:t>
             </a:r>
-            <a:endParaRPr lang="en-US" sz="900" dirty="0"/>
+            <a:endParaRPr lang="en-US" sz="800" dirty="0"/>
           </a:p>
           <a:p>
             <a:pPr marL="152400" indent="-152400">
+              <a:spcBef>
+                <a:spcPts val="500"/>
+              </a:spcBef>
               <a:spcAft>
                 <a:spcPts val="200"/>
               </a:spcAft>
@@ -16211,7 +16343,7 @@
               <a:buChar char="•"/>
             </a:pPr>
             <a:r>
-              <a:rPr lang="en-US" sz="900" dirty="0">
+              <a:rPr lang="en-US" sz="800" dirty="0">
                 <a:solidFill>
                   <a:srgbClr val="1B2559"/>
                 </a:solidFill>
@@ -16221,10 +16353,13 @@
               </a:rPr>
               <a:t>We think it will be popular because…</a:t>
             </a:r>
-            <a:endParaRPr lang="en-US" sz="900" dirty="0"/>
+            <a:endParaRPr lang="en-US" sz="800" dirty="0"/>
           </a:p>
           <a:p>
             <a:pPr marL="152400" indent="-152400">
+              <a:spcBef>
+                <a:spcPts val="500"/>
+              </a:spcBef>
               <a:spcAft>
                 <a:spcPts val="200"/>
               </a:spcAft>
@@ -16232,7 +16367,7 @@
               <a:buChar char="•"/>
             </a:pPr>
             <a:r>
-              <a:rPr lang="en-US" sz="900" dirty="0">
+              <a:rPr lang="en-US" sz="800" dirty="0">
                 <a:solidFill>
                   <a:srgbClr val="1B2559"/>
                 </a:solidFill>
@@ -16242,10 +16377,13 @@
               </a:rPr>
               <a:t>It's easy to use.</a:t>
             </a:r>
-            <a:endParaRPr lang="en-US" sz="900" dirty="0"/>
+            <a:endParaRPr lang="en-US" sz="800" dirty="0"/>
           </a:p>
           <a:p>
             <a:pPr marL="152400" indent="-152400">
+              <a:spcBef>
+                <a:spcPts val="500"/>
+              </a:spcBef>
               <a:spcAft>
                 <a:spcPts val="200"/>
               </a:spcAft>
@@ -16253,7 +16391,7 @@
               <a:buChar char="•"/>
             </a:pPr>
             <a:r>
-              <a:rPr lang="en-US" sz="900" dirty="0">
+              <a:rPr lang="en-US" sz="800" dirty="0">
                 <a:solidFill>
                   <a:srgbClr val="1B2559"/>
                 </a:solidFill>
@@ -16263,7 +16401,7 @@
               </a:rPr>
               <a:t>It's perfect for (+ -ing)…</a:t>
             </a:r>
-            <a:endParaRPr lang="en-US" sz="900" dirty="0"/>
+            <a:endParaRPr lang="en-US" sz="800" dirty="0"/>
           </a:p>
         </p:txBody>
       </p:sp>
@@ -17872,11 +18010,11 @@
         <p:spPr>
           <a:xfrm>
             <a:off x="320040" y="1417320"/>
-            <a:ext cx="2697480" cy="2057400"/>
+            <a:ext cx="2697480" cy="2194560"/>
           </a:xfrm>
           <a:prstGeom prst="roundRect">
             <a:avLst>
-              <a:gd name="adj" fmla="val 6222"/>
+              <a:gd name="adj" fmla="val 5833"/>
             </a:avLst>
           </a:prstGeom>
           <a:solidFill>
@@ -17958,7 +18096,7 @@
               <a:buNone/>
             </a:pPr>
             <a:r>
-              <a:rPr lang="en-US" sz="1500" dirty="0">
+              <a:rPr lang="en-US" sz="1400" dirty="0">
                 <a:solidFill>
                   <a:srgbClr val="1B2559"/>
                 </a:solidFill>
@@ -17968,7 +18106,7 @@
               </a:rPr>
               <a:t>How to play</a:t>
             </a:r>
-            <a:endParaRPr lang="en-US" sz="1500" dirty="0"/>
+            <a:endParaRPr lang="en-US" sz="1400" dirty="0"/>
           </a:p>
         </p:txBody>
       </p:sp>
@@ -17981,7 +18119,7 @@
         <p:spPr>
           <a:xfrm>
             <a:off x="886968" y="1892808"/>
-            <a:ext cx="2039112" cy="1508760"/>
+            <a:ext cx="2039112" cy="1645920"/>
           </a:xfrm>
           <a:prstGeom prst="rect">
             <a:avLst/>
@@ -17995,16 +18133,15 @@
           </a:bodyPr>
           <a:lstStyle/>
           <a:p>
-            <a:pPr marL="177800" indent="-177800">
+            <a:pPr marL="190500" indent="-190500">
               <a:spcAft>
                 <a:spcPts val="200"/>
               </a:spcAft>
               <a:buSzPct val="100000"/>
-              <a:buFont typeface="+mj-lt"/>
-              <a:buAutoNum type="arabicPeriod" startAt="1"/>
-            </a:pPr>
-            <a:r>
-              <a:rPr lang="en-US" sz="1150" dirty="0">
+              <a:buChar char="1"/>
+            </a:pPr>
+            <a:r>
+              <a:rPr lang="en-US" sz="1000" dirty="0">
                 <a:solidFill>
                   <a:srgbClr val="1B2559"/>
                 </a:solidFill>
@@ -18014,41 +18151,42 @@
               </a:rPr>
               <a:t>Pairs: 1-minute pitch.</a:t>
             </a:r>
-            <a:endParaRPr lang="en-US" sz="1150" dirty="0"/>
-          </a:p>
-          <a:p>
-            <a:pPr marL="177800" indent="-177800">
+            <a:endParaRPr lang="en-US" sz="1000" dirty="0"/>
+          </a:p>
+          <a:p>
+            <a:pPr marL="190500" indent="-190500">
               <a:spcAft>
                 <a:spcPts val="200"/>
               </a:spcAft>
               <a:buSzPct val="100000"/>
-              <a:buFont typeface="+mj-lt"/>
-              <a:buAutoNum type="arabicPeriod" startAt="1"/>
-            </a:pPr>
-            <a:r>
-              <a:rPr lang="en-US" sz="1150" dirty="0">
-                <a:solidFill>
-                  <a:srgbClr val="1B2559"/>
+              <a:buChar char="​"/>
+            </a:pPr>
+            <a:r>
+              <a:rPr lang="en-US" sz="900" i="1" dirty="0">
+                <a:solidFill>
+                  <a:srgbClr val="5B6785"/>
                 </a:solidFill>
                 <a:latin typeface="Segoe UI" pitchFamily="34" charset="0"/>
                 <a:ea typeface="Segoe UI" pitchFamily="34" charset="-122"/>
                 <a:cs typeface="Segoe UI" pitchFamily="34" charset="-120"/>
               </a:rPr>
-              <a:t>Dragons: ask one question each.</a:t>
-            </a:r>
-            <a:endParaRPr lang="en-US" sz="1150" dirty="0"/>
-          </a:p>
-          <a:p>
-            <a:pPr marL="177800" indent="-177800">
+              <a:t>Coppie: un minuto di presentazione.</a:t>
+            </a:r>
+            <a:endParaRPr lang="en-US" sz="1000" dirty="0"/>
+          </a:p>
+          <a:p>
+            <a:pPr marL="190500" indent="-190500">
+              <a:spcBef>
+                <a:spcPts val="500"/>
+              </a:spcBef>
               <a:spcAft>
                 <a:spcPts val="200"/>
               </a:spcAft>
               <a:buSzPct val="100000"/>
-              <a:buFont typeface="+mj-lt"/>
-              <a:buAutoNum type="arabicPeriod" startAt="1"/>
-            </a:pPr>
-            <a:r>
-              <a:rPr lang="en-US" sz="1150" dirty="0">
+              <a:buChar char="2"/>
+            </a:pPr>
+            <a:r>
+              <a:rPr lang="en-US" sz="1000" dirty="0">
                 <a:solidFill>
                   <a:srgbClr val="1B2559"/>
                 </a:solidFill>
@@ -18056,9 +18194,75 @@
                 <a:ea typeface="Segoe UI" pitchFamily="34" charset="-122"/>
                 <a:cs typeface="Segoe UI" pitchFamily="34" charset="-120"/>
               </a:rPr>
+              <a:t>Dragons: ask one question each.</a:t>
+            </a:r>
+            <a:endParaRPr lang="en-US" sz="1000" dirty="0"/>
+          </a:p>
+          <a:p>
+            <a:pPr marL="190500" indent="-190500">
+              <a:spcAft>
+                <a:spcPts val="200"/>
+              </a:spcAft>
+              <a:buSzPct val="100000"/>
+              <a:buChar char="​"/>
+            </a:pPr>
+            <a:r>
+              <a:rPr lang="en-US" sz="900" i="1" dirty="0">
+                <a:solidFill>
+                  <a:srgbClr val="5B6785"/>
+                </a:solidFill>
+                <a:latin typeface="Segoe UI" pitchFamily="34" charset="0"/>
+                <a:ea typeface="Segoe UI" pitchFamily="34" charset="-122"/>
+                <a:cs typeface="Segoe UI" pitchFamily="34" charset="-120"/>
+              </a:rPr>
+              <a:t>Dragons: una domanda a testa.</a:t>
+            </a:r>
+            <a:endParaRPr lang="en-US" sz="1000" dirty="0"/>
+          </a:p>
+          <a:p>
+            <a:pPr marL="190500" indent="-190500">
+              <a:spcBef>
+                <a:spcPts val="500"/>
+              </a:spcBef>
+              <a:spcAft>
+                <a:spcPts val="200"/>
+              </a:spcAft>
+              <a:buSzPct val="100000"/>
+              <a:buChar char="3"/>
+            </a:pPr>
+            <a:r>
+              <a:rPr lang="en-US" sz="1000" dirty="0">
+                <a:solidFill>
+                  <a:srgbClr val="1B2559"/>
+                </a:solidFill>
+                <a:latin typeface="Segoe UI" pitchFamily="34" charset="0"/>
+                <a:ea typeface="Segoe UI" pitchFamily="34" charset="-122"/>
+                <a:cs typeface="Segoe UI" pitchFamily="34" charset="-120"/>
+              </a:rPr>
               <a:t>Dragons: invest €… or 'I'm out because…'</a:t>
             </a:r>
-            <a:endParaRPr lang="en-US" sz="1150" dirty="0"/>
+            <a:endParaRPr lang="en-US" sz="1000" dirty="0"/>
+          </a:p>
+          <a:p>
+            <a:pPr marL="190500" indent="-190500">
+              <a:spcAft>
+                <a:spcPts val="200"/>
+              </a:spcAft>
+              <a:buSzPct val="100000"/>
+              <a:buChar char="​"/>
+            </a:pPr>
+            <a:r>
+              <a:rPr lang="en-US" sz="900" i="1" dirty="0">
+                <a:solidFill>
+                  <a:srgbClr val="5B6785"/>
+                </a:solidFill>
+                <a:latin typeface="Segoe UI" pitchFamily="34" charset="0"/>
+                <a:ea typeface="Segoe UI" pitchFamily="34" charset="-122"/>
+                <a:cs typeface="Segoe UI" pitchFamily="34" charset="-120"/>
+              </a:rPr>
+              <a:t>Investite €… o 'I'm out perché…'</a:t>
+            </a:r>
+            <a:endParaRPr lang="en-US" sz="1000" dirty="0"/>
           </a:p>
         </p:txBody>
       </p:sp>
@@ -20283,6 +20487,9 @@
           </a:p>
           <a:p>
             <a:pPr marL="152400" indent="-152400">
+              <a:spcBef>
+                <a:spcPts val="500"/>
+              </a:spcBef>
               <a:spcAft>
                 <a:spcPts val="200"/>
               </a:spcAft>
@@ -20304,6 +20511,9 @@
           </a:p>
           <a:p>
             <a:pPr marL="152400" indent="-152400">
+              <a:spcBef>
+                <a:spcPts val="500"/>
+              </a:spcBef>
               <a:spcAft>
                 <a:spcPts val="200"/>
               </a:spcAft>
@@ -20943,11 +21153,11 @@
         <p:spPr>
           <a:xfrm>
             <a:off x="320040" y="1417320"/>
-            <a:ext cx="2697480" cy="2057400"/>
+            <a:ext cx="2697480" cy="2194560"/>
           </a:xfrm>
           <a:prstGeom prst="roundRect">
             <a:avLst>
-              <a:gd name="adj" fmla="val 6222"/>
+              <a:gd name="adj" fmla="val 5833"/>
             </a:avLst>
           </a:prstGeom>
           <a:solidFill>
@@ -21029,7 +21239,7 @@
               <a:buNone/>
             </a:pPr>
             <a:r>
-              <a:rPr lang="en-US" sz="1500" dirty="0">
+              <a:rPr lang="en-US" sz="1400" dirty="0">
                 <a:solidFill>
                   <a:srgbClr val="1B2559"/>
                 </a:solidFill>
@@ -21039,7 +21249,7 @@
               </a:rPr>
               <a:t>How to play</a:t>
             </a:r>
-            <a:endParaRPr lang="en-US" sz="1500" dirty="0"/>
+            <a:endParaRPr lang="en-US" sz="1400" dirty="0"/>
           </a:p>
         </p:txBody>
       </p:sp>
@@ -21052,7 +21262,7 @@
         <p:spPr>
           <a:xfrm>
             <a:off x="886968" y="1892808"/>
-            <a:ext cx="2039112" cy="1508760"/>
+            <a:ext cx="2039112" cy="1645920"/>
           </a:xfrm>
           <a:prstGeom prst="rect">
             <a:avLst/>
@@ -21066,16 +21276,15 @@
           </a:bodyPr>
           <a:lstStyle/>
           <a:p>
-            <a:pPr marL="177800" indent="-177800">
+            <a:pPr marL="190500" indent="-190500">
               <a:spcAft>
                 <a:spcPts val="200"/>
               </a:spcAft>
               <a:buSzPct val="100000"/>
-              <a:buFont typeface="+mj-lt"/>
-              <a:buAutoNum type="arabicPeriod" startAt="1"/>
-            </a:pPr>
-            <a:r>
-              <a:rPr lang="en-US" sz="1150" dirty="0">
+              <a:buChar char="1"/>
+            </a:pPr>
+            <a:r>
+              <a:rPr lang="en-US" sz="1100" dirty="0">
                 <a:solidFill>
                   <a:srgbClr val="1B2559"/>
                 </a:solidFill>
@@ -21085,41 +21294,42 @@
               </a:rPr>
               <a:t>Take a useless product.</a:t>
             </a:r>
-            <a:endParaRPr lang="en-US" sz="1150" dirty="0"/>
-          </a:p>
-          <a:p>
-            <a:pPr marL="177800" indent="-177800">
+            <a:endParaRPr lang="en-US" sz="1100" dirty="0"/>
+          </a:p>
+          <a:p>
+            <a:pPr marL="190500" indent="-190500">
               <a:spcAft>
                 <a:spcPts val="200"/>
               </a:spcAft>
               <a:buSzPct val="100000"/>
-              <a:buFont typeface="+mj-lt"/>
-              <a:buAutoNum type="arabicPeriod" startAt="1"/>
-            </a:pPr>
-            <a:r>
-              <a:rPr lang="en-US" sz="1150" dirty="0">
-                <a:solidFill>
-                  <a:srgbClr val="1B2559"/>
+              <a:buChar char="​"/>
+            </a:pPr>
+            <a:r>
+              <a:rPr lang="en-US" sz="950" i="1" dirty="0">
+                <a:solidFill>
+                  <a:srgbClr val="5B6785"/>
                 </a:solidFill>
                 <a:latin typeface="Segoe UI" pitchFamily="34" charset="0"/>
                 <a:ea typeface="Segoe UI" pitchFamily="34" charset="-122"/>
                 <a:cs typeface="Segoe UI" pitchFamily="34" charset="-120"/>
               </a:rPr>
-              <a:t>3 minutes: find 3 'advantages' + a slogan.</a:t>
-            </a:r>
-            <a:endParaRPr lang="en-US" sz="1150" dirty="0"/>
-          </a:p>
-          <a:p>
-            <a:pPr marL="177800" indent="-177800">
+              <a:t>Prendete un prodotto inutile.</a:t>
+            </a:r>
+            <a:endParaRPr lang="en-US" sz="1100" dirty="0"/>
+          </a:p>
+          <a:p>
+            <a:pPr marL="190500" indent="-190500">
+              <a:spcBef>
+                <a:spcPts val="500"/>
+              </a:spcBef>
               <a:spcAft>
                 <a:spcPts val="200"/>
               </a:spcAft>
               <a:buSzPct val="100000"/>
-              <a:buFont typeface="+mj-lt"/>
-              <a:buAutoNum type="arabicPeriod" startAt="1"/>
-            </a:pPr>
-            <a:r>
-              <a:rPr lang="en-US" sz="1150" dirty="0">
+              <a:buChar char="2"/>
+            </a:pPr>
+            <a:r>
+              <a:rPr lang="en-US" sz="1100" dirty="0">
                 <a:solidFill>
                   <a:srgbClr val="1B2559"/>
                 </a:solidFill>
@@ -21127,9 +21337,75 @@
                 <a:ea typeface="Segoe UI" pitchFamily="34" charset="-122"/>
                 <a:cs typeface="Segoe UI" pitchFamily="34" charset="-120"/>
               </a:rPr>
+              <a:t>3 minutes: find 3 'advantages' + a slogan.</a:t>
+            </a:r>
+            <a:endParaRPr lang="en-US" sz="1100" dirty="0"/>
+          </a:p>
+          <a:p>
+            <a:pPr marL="190500" indent="-190500">
+              <a:spcAft>
+                <a:spcPts val="200"/>
+              </a:spcAft>
+              <a:buSzPct val="100000"/>
+              <a:buChar char="​"/>
+            </a:pPr>
+            <a:r>
+              <a:rPr lang="en-US" sz="950" i="1" dirty="0">
+                <a:solidFill>
+                  <a:srgbClr val="5B6785"/>
+                </a:solidFill>
+                <a:latin typeface="Segoe UI" pitchFamily="34" charset="0"/>
+                <a:ea typeface="Segoe UI" pitchFamily="34" charset="-122"/>
+                <a:cs typeface="Segoe UI" pitchFamily="34" charset="-120"/>
+              </a:rPr>
+              <a:t>3 minuti: 3 'vantaggi' + uno slogan.</a:t>
+            </a:r>
+            <a:endParaRPr lang="en-US" sz="1100" dirty="0"/>
+          </a:p>
+          <a:p>
+            <a:pPr marL="190500" indent="-190500">
+              <a:spcBef>
+                <a:spcPts val="500"/>
+              </a:spcBef>
+              <a:spcAft>
+                <a:spcPts val="200"/>
+              </a:spcAft>
+              <a:buSzPct val="100000"/>
+              <a:buChar char="3"/>
+            </a:pPr>
+            <a:r>
+              <a:rPr lang="en-US" sz="1100" dirty="0">
+                <a:solidFill>
+                  <a:srgbClr val="1B2559"/>
+                </a:solidFill>
+                <a:latin typeface="Segoe UI" pitchFamily="34" charset="0"/>
+                <a:ea typeface="Segoe UI" pitchFamily="34" charset="-122"/>
+                <a:cs typeface="Segoe UI" pitchFamily="34" charset="-120"/>
+              </a:rPr>
               <a:t>Pitch it. Dragons: keep a straight face!</a:t>
             </a:r>
-            <a:endParaRPr lang="en-US" sz="1150" dirty="0"/>
+            <a:endParaRPr lang="en-US" sz="1100" dirty="0"/>
+          </a:p>
+          <a:p>
+            <a:pPr marL="190500" indent="-190500">
+              <a:spcAft>
+                <a:spcPts val="200"/>
+              </a:spcAft>
+              <a:buSzPct val="100000"/>
+              <a:buChar char="​"/>
+            </a:pPr>
+            <a:r>
+              <a:rPr lang="en-US" sz="950" i="1" dirty="0">
+                <a:solidFill>
+                  <a:srgbClr val="5B6785"/>
+                </a:solidFill>
+                <a:latin typeface="Segoe UI" pitchFamily="34" charset="0"/>
+                <a:ea typeface="Segoe UI" pitchFamily="34" charset="-122"/>
+                <a:cs typeface="Segoe UI" pitchFamily="34" charset="-120"/>
+              </a:rPr>
+              <a:t>Presentate. Dragons: niente risate!</a:t>
+            </a:r>
+            <a:endParaRPr lang="en-US" sz="1100" dirty="0"/>
           </a:p>
         </p:txBody>
       </p:sp>
@@ -22763,6 +23039,9 @@
           </a:p>
           <a:p>
             <a:pPr marL="152400" indent="-152400">
+              <a:spcBef>
+                <a:spcPts val="500"/>
+              </a:spcBef>
               <a:spcAft>
                 <a:spcPts val="200"/>
               </a:spcAft>
@@ -24318,7 +24597,7 @@
               <a:buChar char="•"/>
             </a:pPr>
             <a:r>
-              <a:rPr lang="en-US" sz="1050" dirty="0">
+              <a:rPr lang="en-US" sz="950" dirty="0">
                 <a:solidFill>
                   <a:srgbClr val="1B2559"/>
                 </a:solidFill>
@@ -24328,10 +24607,13 @@
               </a:rPr>
               <a:t>I'm good at -ing · I enjoy -ing</a:t>
             </a:r>
-            <a:endParaRPr lang="en-US" sz="1050" dirty="0"/>
+            <a:endParaRPr lang="en-US" sz="950" dirty="0"/>
           </a:p>
           <a:p>
             <a:pPr marL="152400" indent="-152400">
+              <a:spcBef>
+                <a:spcPts val="500"/>
+              </a:spcBef>
               <a:spcAft>
                 <a:spcPts val="200"/>
               </a:spcAft>
@@ -24339,7 +24621,7 @@
               <a:buChar char="•"/>
             </a:pPr>
             <a:r>
-              <a:rPr lang="en-US" sz="1050" dirty="0">
+              <a:rPr lang="en-US" sz="950" dirty="0">
                 <a:solidFill>
                   <a:srgbClr val="1B2559"/>
                 </a:solidFill>
@@ -24349,10 +24631,13 @@
               </a:rPr>
               <a:t>I'd like to… · I'd love to…</a:t>
             </a:r>
-            <a:endParaRPr lang="en-US" sz="1050" dirty="0"/>
+            <a:endParaRPr lang="en-US" sz="950" dirty="0"/>
           </a:p>
           <a:p>
             <a:pPr marL="152400" indent="-152400">
+              <a:spcBef>
+                <a:spcPts val="500"/>
+              </a:spcBef>
               <a:spcAft>
                 <a:spcPts val="200"/>
               </a:spcAft>
@@ -24360,7 +24645,7 @@
               <a:buChar char="•"/>
             </a:pPr>
             <a:r>
-              <a:rPr lang="en-US" sz="1050" dirty="0">
+              <a:rPr lang="en-US" sz="950" dirty="0">
                 <a:solidFill>
                   <a:srgbClr val="1B2559"/>
                 </a:solidFill>
@@ -24370,7 +24655,7 @@
               </a:rPr>
               <a:t>I've worked as a… · I don't mind -ing</a:t>
             </a:r>
-            <a:endParaRPr lang="en-US" sz="1050" dirty="0"/>
+            <a:endParaRPr lang="en-US" sz="950" dirty="0"/>
           </a:p>
         </p:txBody>
       </p:sp>
@@ -25979,11 +26264,11 @@
         <p:spPr>
           <a:xfrm>
             <a:off x="320040" y="1417320"/>
-            <a:ext cx="2697480" cy="2057400"/>
+            <a:ext cx="2697480" cy="2194560"/>
           </a:xfrm>
           <a:prstGeom prst="roundRect">
             <a:avLst>
-              <a:gd name="adj" fmla="val 6222"/>
+              <a:gd name="adj" fmla="val 5833"/>
             </a:avLst>
           </a:prstGeom>
           <a:solidFill>
@@ -26065,7 +26350,7 @@
               <a:buNone/>
             </a:pPr>
             <a:r>
-              <a:rPr lang="en-US" sz="1500" dirty="0">
+              <a:rPr lang="en-US" sz="1400" dirty="0">
                 <a:solidFill>
                   <a:srgbClr val="1B2559"/>
                 </a:solidFill>
@@ -26075,7 +26360,7 @@
               </a:rPr>
               <a:t>How to play</a:t>
             </a:r>
-            <a:endParaRPr lang="en-US" sz="1500" dirty="0"/>
+            <a:endParaRPr lang="en-US" sz="1400" dirty="0"/>
           </a:p>
         </p:txBody>
       </p:sp>
@@ -26088,7 +26373,7 @@
         <p:spPr>
           <a:xfrm>
             <a:off x="886968" y="1892808"/>
-            <a:ext cx="2039112" cy="1508760"/>
+            <a:ext cx="2039112" cy="1645920"/>
           </a:xfrm>
           <a:prstGeom prst="rect">
             <a:avLst/>
@@ -26102,13 +26387,12 @@
           </a:bodyPr>
           <a:lstStyle/>
           <a:p>
-            <a:pPr marL="177800" indent="-177800">
+            <a:pPr marL="190500" indent="-190500">
               <a:spcAft>
                 <a:spcPts val="200"/>
               </a:spcAft>
               <a:buSzPct val="100000"/>
-              <a:buFont typeface="+mj-lt"/>
-              <a:buAutoNum type="arabicPeriod" startAt="1"/>
+              <a:buChar char="1"/>
             </a:pPr>
             <a:r>
               <a:rPr lang="en-US" sz="1150" dirty="0">
@@ -26124,35 +26408,36 @@
             <a:endParaRPr lang="en-US" sz="1150" dirty="0"/>
           </a:p>
           <a:p>
-            <a:pPr marL="177800" indent="-177800">
+            <a:pPr marL="190500" indent="-190500">
               <a:spcAft>
                 <a:spcPts val="200"/>
               </a:spcAft>
               <a:buSzPct val="100000"/>
-              <a:buFont typeface="+mj-lt"/>
-              <a:buAutoNum type="arabicPeriod" startAt="1"/>
-            </a:pPr>
-            <a:r>
-              <a:rPr lang="en-US" sz="1150" dirty="0">
-                <a:solidFill>
-                  <a:srgbClr val="1B2559"/>
+              <a:buChar char="​"/>
+            </a:pPr>
+            <a:r>
+              <a:rPr lang="en-US" sz="1000" i="1" dirty="0">
+                <a:solidFill>
+                  <a:srgbClr val="5B6785"/>
                 </a:solidFill>
                 <a:latin typeface="Segoe UI" pitchFamily="34" charset="0"/>
                 <a:ea typeface="Segoe UI" pitchFamily="34" charset="-122"/>
                 <a:cs typeface="Segoe UI" pitchFamily="34" charset="-120"/>
               </a:rPr>
-              <a:t>to + infinitive → SIT DOWN.</a:t>
+              <a:t>-ing → IN PIEDI.</a:t>
             </a:r>
             <a:endParaRPr lang="en-US" sz="1150" dirty="0"/>
           </a:p>
           <a:p>
-            <a:pPr marL="177800" indent="-177800">
+            <a:pPr marL="190500" indent="-190500">
+              <a:spcBef>
+                <a:spcPts val="500"/>
+              </a:spcBef>
               <a:spcAft>
                 <a:spcPts val="200"/>
               </a:spcAft>
               <a:buSzPct val="100000"/>
-              <a:buFont typeface="+mj-lt"/>
-              <a:buAutoNum type="arabicPeriod" startAt="1"/>
+              <a:buChar char="2"/>
             </a:pPr>
             <a:r>
               <a:rPr lang="en-US" sz="1150" dirty="0">
@@ -26163,7 +26448,73 @@
                 <a:ea typeface="Segoe UI" pitchFamily="34" charset="-122"/>
                 <a:cs typeface="Segoe UI" pitchFamily="34" charset="-120"/>
               </a:rPr>
+              <a:t>to + infinitive → SIT DOWN.</a:t>
+            </a:r>
+            <a:endParaRPr lang="en-US" sz="1150" dirty="0"/>
+          </a:p>
+          <a:p>
+            <a:pPr marL="190500" indent="-190500">
+              <a:spcAft>
+                <a:spcPts val="200"/>
+              </a:spcAft>
+              <a:buSzPct val="100000"/>
+              <a:buChar char="​"/>
+            </a:pPr>
+            <a:r>
+              <a:rPr lang="en-US" sz="1000" i="1" dirty="0">
+                <a:solidFill>
+                  <a:srgbClr val="5B6785"/>
+                </a:solidFill>
+                <a:latin typeface="Segoe UI" pitchFamily="34" charset="0"/>
+                <a:ea typeface="Segoe UI" pitchFamily="34" charset="-122"/>
+                <a:cs typeface="Segoe UI" pitchFamily="34" charset="-120"/>
+              </a:rPr>
+              <a:t>to + infinito → SEDUTI.</a:t>
+            </a:r>
+            <a:endParaRPr lang="en-US" sz="1150" dirty="0"/>
+          </a:p>
+          <a:p>
+            <a:pPr marL="190500" indent="-190500">
+              <a:spcBef>
+                <a:spcPts val="500"/>
+              </a:spcBef>
+              <a:spcAft>
+                <a:spcPts val="200"/>
+              </a:spcAft>
+              <a:buSzPct val="100000"/>
+              <a:buChar char="3"/>
+            </a:pPr>
+            <a:r>
+              <a:rPr lang="en-US" sz="1150" dirty="0">
+                <a:solidFill>
+                  <a:srgbClr val="1B2559"/>
+                </a:solidFill>
+                <a:latin typeface="Segoe UI" pitchFamily="34" charset="0"/>
+                <a:ea typeface="Segoe UI" pitchFamily="34" charset="-122"/>
+                <a:cs typeface="Segoe UI" pitchFamily="34" charset="-120"/>
+              </a:rPr>
               <a:t>infinitive (no to) → HANDS UP!</a:t>
+            </a:r>
+            <a:endParaRPr lang="en-US" sz="1150" dirty="0"/>
+          </a:p>
+          <a:p>
+            <a:pPr marL="190500" indent="-190500">
+              <a:spcAft>
+                <a:spcPts val="200"/>
+              </a:spcAft>
+              <a:buSzPct val="100000"/>
+              <a:buChar char="​"/>
+            </a:pPr>
+            <a:r>
+              <a:rPr lang="en-US" sz="1000" i="1" dirty="0">
+                <a:solidFill>
+                  <a:srgbClr val="5B6785"/>
+                </a:solidFill>
+                <a:latin typeface="Segoe UI" pitchFamily="34" charset="0"/>
+                <a:ea typeface="Segoe UI" pitchFamily="34" charset="-122"/>
+                <a:cs typeface="Segoe UI" pitchFamily="34" charset="-120"/>
+              </a:rPr>
+              <a:t>infinito senza to → MANI SU!</a:t>
             </a:r>
             <a:endParaRPr lang="en-US" sz="1150" dirty="0"/>
           </a:p>
@@ -31035,7 +31386,7 @@
       </p:sp>
       <p:sp>
         <p:nvSpPr>
-          <p:cNvPr id="21" name="R1_it149"/>
+          <p:cNvPr id="21" name="R2_it149"/>
           <p:cNvSpPr/>
           <p:nvPr/>
         </p:nvSpPr>
@@ -31189,7 +31540,7 @@
       </p:sp>
       <p:sp>
         <p:nvSpPr>
-          <p:cNvPr id="25" name="R1_it153"/>
+          <p:cNvPr id="25" name="R3_it153"/>
           <p:cNvSpPr/>
           <p:nvPr/>
         </p:nvSpPr>
@@ -31343,7 +31694,7 @@
       </p:sp>
       <p:sp>
         <p:nvSpPr>
-          <p:cNvPr id="29" name="R1_it157"/>
+          <p:cNvPr id="29" name="R4_it157"/>
           <p:cNvSpPr/>
           <p:nvPr/>
         </p:nvSpPr>
@@ -31497,7 +31848,7 @@
       </p:sp>
       <p:sp>
         <p:nvSpPr>
-          <p:cNvPr id="33" name="R1_it161"/>
+          <p:cNvPr id="33" name="R5_it161"/>
           <p:cNvSpPr/>
           <p:nvPr/>
         </p:nvSpPr>
@@ -31651,7 +32002,7 @@
       </p:sp>
       <p:sp>
         <p:nvSpPr>
-          <p:cNvPr id="37" name="R1_it165"/>
+          <p:cNvPr id="37" name="R6_it165"/>
           <p:cNvSpPr/>
           <p:nvPr/>
         </p:nvSpPr>
@@ -31805,7 +32156,7 @@
       </p:sp>
       <p:sp>
         <p:nvSpPr>
-          <p:cNvPr id="41" name="R1_it169"/>
+          <p:cNvPr id="41" name="R7_it169"/>
           <p:cNvSpPr/>
           <p:nvPr/>
         </p:nvSpPr>
@@ -31959,7 +32310,7 @@
       </p:sp>
       <p:sp>
         <p:nvSpPr>
-          <p:cNvPr id="45" name="R1_it173"/>
+          <p:cNvPr id="45" name="R8_it173"/>
           <p:cNvSpPr/>
           <p:nvPr/>
         </p:nvSpPr>
@@ -32113,7 +32464,7 @@
       </p:sp>
       <p:sp>
         <p:nvSpPr>
-          <p:cNvPr id="49" name="R1_it177"/>
+          <p:cNvPr id="49" name="R9_it177"/>
           <p:cNvSpPr/>
           <p:nvPr/>
         </p:nvSpPr>
@@ -32267,7 +32618,7 @@
       </p:sp>
       <p:sp>
         <p:nvSpPr>
-          <p:cNvPr id="53" name="R1_it181"/>
+          <p:cNvPr id="53" name="R10_it181"/>
           <p:cNvSpPr/>
           <p:nvPr/>
         </p:nvSpPr>
@@ -32421,7 +32772,7 @@
       </p:sp>
       <p:sp>
         <p:nvSpPr>
-          <p:cNvPr id="57" name="R1_it185"/>
+          <p:cNvPr id="57" name="R11_it185"/>
           <p:cNvSpPr/>
           <p:nvPr/>
         </p:nvSpPr>
@@ -32575,7 +32926,7 @@
       </p:sp>
       <p:sp>
         <p:nvSpPr>
-          <p:cNvPr id="61" name="R1_it189"/>
+          <p:cNvPr id="61" name="R12_it189"/>
           <p:cNvSpPr/>
           <p:nvPr/>
         </p:nvSpPr>
@@ -32616,7 +32967,7 @@
       </p:sp>
       <p:sp>
         <p:nvSpPr>
-          <p:cNvPr id="62" name="R1_wc190"/>
+          <p:cNvPr id="62" name="R13_wc190"/>
           <p:cNvSpPr/>
           <p:nvPr/>
         </p:nvSpPr>
@@ -32650,7 +33001,7 @@
       </p:sp>
       <p:sp>
         <p:nvSpPr>
-          <p:cNvPr id="63" name="R1_w191"/>
+          <p:cNvPr id="63" name="R13_w191"/>
           <p:cNvSpPr/>
           <p:nvPr/>
         </p:nvSpPr>
@@ -32752,15 +33103,33 @@
                                   </p:childTnLst>
                                 </p:cTn>
                               </p:par>
+                            </p:childTnLst>
+                          </p:cTn>
+                        </p:par>
+                      </p:childTnLst>
+                    </p:cTn>
+                  </p:par>
+                  <p:par>
+                    <p:cTn id="8" fill="hold">
+                      <p:stCondLst>
+                        <p:cond delay="indefinite"/>
+                      </p:stCondLst>
+                      <p:childTnLst>
+                        <p:par>
+                          <p:cTn id="9" fill="hold">
+                            <p:stCondLst>
+                              <p:cond delay="0"/>
+                            </p:stCondLst>
+                            <p:childTnLst>
                               <p:par>
-                                <p:cTn id="8" presetID="10" presetClass="entr" presetSubtype="0" fill="hold" nodeType="withEffect">
+                                <p:cTn id="10" presetID="10" presetClass="entr" presetSubtype="0" fill="hold" nodeType="clickEffect">
                                   <p:stCondLst>
                                     <p:cond delay="0"/>
                                   </p:stCondLst>
                                   <p:childTnLst>
                                     <p:set>
                                       <p:cBhvr>
-                                        <p:cTn id="9" dur="1" fill="hold">
+                                        <p:cTn id="11" dur="1" fill="hold">
                                           <p:stCondLst>
                                             <p:cond delay="0"/>
                                           </p:stCondLst>
@@ -32778,7 +33147,7 @@
                                     </p:set>
                                     <p:animEffect transition="in" filter="fade">
                                       <p:cBhvr>
-                                        <p:cTn id="10" dur="400"/>
+                                        <p:cTn id="12" dur="400"/>
                                         <p:tgtEl>
                                           <p:spTgt spid="21"/>
                                         </p:tgtEl>
@@ -32787,15 +33156,33 @@
                                   </p:childTnLst>
                                 </p:cTn>
                               </p:par>
+                            </p:childTnLst>
+                          </p:cTn>
+                        </p:par>
+                      </p:childTnLst>
+                    </p:cTn>
+                  </p:par>
+                  <p:par>
+                    <p:cTn id="13" fill="hold">
+                      <p:stCondLst>
+                        <p:cond delay="indefinite"/>
+                      </p:stCondLst>
+                      <p:childTnLst>
+                        <p:par>
+                          <p:cTn id="14" fill="hold">
+                            <p:stCondLst>
+                              <p:cond delay="0"/>
+                            </p:stCondLst>
+                            <p:childTnLst>
                               <p:par>
-                                <p:cTn id="11" presetID="10" presetClass="entr" presetSubtype="0" fill="hold" nodeType="withEffect">
+                                <p:cTn id="15" presetID="10" presetClass="entr" presetSubtype="0" fill="hold" nodeType="clickEffect">
                                   <p:stCondLst>
                                     <p:cond delay="0"/>
                                   </p:stCondLst>
                                   <p:childTnLst>
                                     <p:set>
                                       <p:cBhvr>
-                                        <p:cTn id="12" dur="1" fill="hold">
+                                        <p:cTn id="16" dur="1" fill="hold">
                                           <p:stCondLst>
                                             <p:cond delay="0"/>
                                           </p:stCondLst>
@@ -32813,7 +33200,7 @@
                                     </p:set>
                                     <p:animEffect transition="in" filter="fade">
                                       <p:cBhvr>
-                                        <p:cTn id="13" dur="400"/>
+                                        <p:cTn id="17" dur="400"/>
                                         <p:tgtEl>
                                           <p:spTgt spid="25"/>
                                         </p:tgtEl>
@@ -32822,15 +33209,33 @@
                                   </p:childTnLst>
                                 </p:cTn>
                               </p:par>
+                            </p:childTnLst>
+                          </p:cTn>
+                        </p:par>
+                      </p:childTnLst>
+                    </p:cTn>
+                  </p:par>
+                  <p:par>
+                    <p:cTn id="18" fill="hold">
+                      <p:stCondLst>
+                        <p:cond delay="indefinite"/>
+                      </p:stCondLst>
+                      <p:childTnLst>
+                        <p:par>
+                          <p:cTn id="19" fill="hold">
+                            <p:stCondLst>
+                              <p:cond delay="0"/>
+                            </p:stCondLst>
+                            <p:childTnLst>
                               <p:par>
-                                <p:cTn id="14" presetID="10" presetClass="entr" presetSubtype="0" fill="hold" nodeType="withEffect">
+                                <p:cTn id="20" presetID="10" presetClass="entr" presetSubtype="0" fill="hold" nodeType="clickEffect">
                                   <p:stCondLst>
                                     <p:cond delay="0"/>
                                   </p:stCondLst>
                                   <p:childTnLst>
                                     <p:set>
                                       <p:cBhvr>
-                                        <p:cTn id="15" dur="1" fill="hold">
+                                        <p:cTn id="21" dur="1" fill="hold">
                                           <p:stCondLst>
                                             <p:cond delay="0"/>
                                           </p:stCondLst>
@@ -32848,7 +33253,7 @@
                                     </p:set>
                                     <p:animEffect transition="in" filter="fade">
                                       <p:cBhvr>
-                                        <p:cTn id="16" dur="400"/>
+                                        <p:cTn id="22" dur="400"/>
                                         <p:tgtEl>
                                           <p:spTgt spid="29"/>
                                         </p:tgtEl>
@@ -32857,15 +33262,33 @@
                                   </p:childTnLst>
                                 </p:cTn>
                               </p:par>
+                            </p:childTnLst>
+                          </p:cTn>
+                        </p:par>
+                      </p:childTnLst>
+                    </p:cTn>
+                  </p:par>
+                  <p:par>
+                    <p:cTn id="23" fill="hold">
+                      <p:stCondLst>
+                        <p:cond delay="indefinite"/>
+                      </p:stCondLst>
+                      <p:childTnLst>
+                        <p:par>
+                          <p:cTn id="24" fill="hold">
+                            <p:stCondLst>
+                              <p:cond delay="0"/>
+                            </p:stCondLst>
+                            <p:childTnLst>
                               <p:par>
-                                <p:cTn id="17" presetID="10" presetClass="entr" presetSubtype="0" fill="hold" nodeType="withEffect">
+                                <p:cTn id="25" presetID="10" presetClass="entr" presetSubtype="0" fill="hold" nodeType="clickEffect">
                                   <p:stCondLst>
                                     <p:cond delay="0"/>
                                   </p:stCondLst>
                                   <p:childTnLst>
                                     <p:set>
                                       <p:cBhvr>
-                                        <p:cTn id="18" dur="1" fill="hold">
+                                        <p:cTn id="26" dur="1" fill="hold">
                                           <p:stCondLst>
                                             <p:cond delay="0"/>
                                           </p:stCondLst>
@@ -32883,7 +33306,7 @@
                                     </p:set>
                                     <p:animEffect transition="in" filter="fade">
                                       <p:cBhvr>
-                                        <p:cTn id="19" dur="400"/>
+                                        <p:cTn id="27" dur="400"/>
                                         <p:tgtEl>
                                           <p:spTgt spid="33"/>
                                         </p:tgtEl>
@@ -32892,15 +33315,33 @@
                                   </p:childTnLst>
                                 </p:cTn>
                               </p:par>
+                            </p:childTnLst>
+                          </p:cTn>
+                        </p:par>
+                      </p:childTnLst>
+                    </p:cTn>
+                  </p:par>
+                  <p:par>
+                    <p:cTn id="28" fill="hold">
+                      <p:stCondLst>
+                        <p:cond delay="indefinite"/>
+                      </p:stCondLst>
+                      <p:childTnLst>
+                        <p:par>
+                          <p:cTn id="29" fill="hold">
+                            <p:stCondLst>
+                              <p:cond delay="0"/>
+                            </p:stCondLst>
+                            <p:childTnLst>
                               <p:par>
-                                <p:cTn id="20" presetID="10" presetClass="entr" presetSubtype="0" fill="hold" nodeType="withEffect">
+                                <p:cTn id="30" presetID="10" presetClass="entr" presetSubtype="0" fill="hold" nodeType="clickEffect">
                                   <p:stCondLst>
                                     <p:cond delay="0"/>
                                   </p:stCondLst>
                                   <p:childTnLst>
                                     <p:set>
                                       <p:cBhvr>
-                                        <p:cTn id="21" dur="1" fill="hold">
+                                        <p:cTn id="31" dur="1" fill="hold">
                                           <p:stCondLst>
                                             <p:cond delay="0"/>
                                           </p:stCondLst>
@@ -32918,7 +33359,7 @@
                                     </p:set>
                                     <p:animEffect transition="in" filter="fade">
                                       <p:cBhvr>
-                                        <p:cTn id="22" dur="400"/>
+                                        <p:cTn id="32" dur="400"/>
                                         <p:tgtEl>
                                           <p:spTgt spid="37"/>
                                         </p:tgtEl>
@@ -32927,15 +33368,33 @@
                                   </p:childTnLst>
                                 </p:cTn>
                               </p:par>
+                            </p:childTnLst>
+                          </p:cTn>
+                        </p:par>
+                      </p:childTnLst>
+                    </p:cTn>
+                  </p:par>
+                  <p:par>
+                    <p:cTn id="33" fill="hold">
+                      <p:stCondLst>
+                        <p:cond delay="indefinite"/>
+                      </p:stCondLst>
+                      <p:childTnLst>
+                        <p:par>
+                          <p:cTn id="34" fill="hold">
+                            <p:stCondLst>
+                              <p:cond delay="0"/>
+                            </p:stCondLst>
+                            <p:childTnLst>
                               <p:par>
-                                <p:cTn id="23" presetID="10" presetClass="entr" presetSubtype="0" fill="hold" nodeType="withEffect">
+                                <p:cTn id="35" presetID="10" presetClass="entr" presetSubtype="0" fill="hold" nodeType="clickEffect">
                                   <p:stCondLst>
                                     <p:cond delay="0"/>
                                   </p:stCondLst>
                                   <p:childTnLst>
                                     <p:set>
                                       <p:cBhvr>
-                                        <p:cTn id="24" dur="1" fill="hold">
+                                        <p:cTn id="36" dur="1" fill="hold">
                                           <p:stCondLst>
                                             <p:cond delay="0"/>
                                           </p:stCondLst>
@@ -32953,7 +33412,7 @@
                                     </p:set>
                                     <p:animEffect transition="in" filter="fade">
                                       <p:cBhvr>
-                                        <p:cTn id="25" dur="400"/>
+                                        <p:cTn id="37" dur="400"/>
                                         <p:tgtEl>
                                           <p:spTgt spid="41"/>
                                         </p:tgtEl>
@@ -32962,15 +33421,33 @@
                                   </p:childTnLst>
                                 </p:cTn>
                               </p:par>
+                            </p:childTnLst>
+                          </p:cTn>
+                        </p:par>
+                      </p:childTnLst>
+                    </p:cTn>
+                  </p:par>
+                  <p:par>
+                    <p:cTn id="38" fill="hold">
+                      <p:stCondLst>
+                        <p:cond delay="indefinite"/>
+                      </p:stCondLst>
+                      <p:childTnLst>
+                        <p:par>
+                          <p:cTn id="39" fill="hold">
+                            <p:stCondLst>
+                              <p:cond delay="0"/>
+                            </p:stCondLst>
+                            <p:childTnLst>
                               <p:par>
-                                <p:cTn id="26" presetID="10" presetClass="entr" presetSubtype="0" fill="hold" nodeType="withEffect">
+                                <p:cTn id="40" presetID="10" presetClass="entr" presetSubtype="0" fill="hold" nodeType="clickEffect">
                                   <p:stCondLst>
                                     <p:cond delay="0"/>
                                   </p:stCondLst>
                                   <p:childTnLst>
                                     <p:set>
                                       <p:cBhvr>
-                                        <p:cTn id="27" dur="1" fill="hold">
+                                        <p:cTn id="41" dur="1" fill="hold">
                                           <p:stCondLst>
                                             <p:cond delay="0"/>
                                           </p:stCondLst>
@@ -32988,7 +33465,7 @@
                                     </p:set>
                                     <p:animEffect transition="in" filter="fade">
                                       <p:cBhvr>
-                                        <p:cTn id="28" dur="400"/>
+                                        <p:cTn id="42" dur="400"/>
                                         <p:tgtEl>
                                           <p:spTgt spid="45"/>
                                         </p:tgtEl>
@@ -32997,15 +33474,33 @@
                                   </p:childTnLst>
                                 </p:cTn>
                               </p:par>
+                            </p:childTnLst>
+                          </p:cTn>
+                        </p:par>
+                      </p:childTnLst>
+                    </p:cTn>
+                  </p:par>
+                  <p:par>
+                    <p:cTn id="43" fill="hold">
+                      <p:stCondLst>
+                        <p:cond delay="indefinite"/>
+                      </p:stCondLst>
+                      <p:childTnLst>
+                        <p:par>
+                          <p:cTn id="44" fill="hold">
+                            <p:stCondLst>
+                              <p:cond delay="0"/>
+                            </p:stCondLst>
+                            <p:childTnLst>
                               <p:par>
-                                <p:cTn id="29" presetID="10" presetClass="entr" presetSubtype="0" fill="hold" nodeType="withEffect">
+                                <p:cTn id="45" presetID="10" presetClass="entr" presetSubtype="0" fill="hold" nodeType="clickEffect">
                                   <p:stCondLst>
                                     <p:cond delay="0"/>
                                   </p:stCondLst>
                                   <p:childTnLst>
                                     <p:set>
                                       <p:cBhvr>
-                                        <p:cTn id="30" dur="1" fill="hold">
+                                        <p:cTn id="46" dur="1" fill="hold">
                                           <p:stCondLst>
                                             <p:cond delay="0"/>
                                           </p:stCondLst>
@@ -33023,7 +33518,7 @@
                                     </p:set>
                                     <p:animEffect transition="in" filter="fade">
                                       <p:cBhvr>
-                                        <p:cTn id="31" dur="400"/>
+                                        <p:cTn id="47" dur="400"/>
                                         <p:tgtEl>
                                           <p:spTgt spid="49"/>
                                         </p:tgtEl>
@@ -33032,15 +33527,33 @@
                                   </p:childTnLst>
                                 </p:cTn>
                               </p:par>
+                            </p:childTnLst>
+                          </p:cTn>
+                        </p:par>
+                      </p:childTnLst>
+                    </p:cTn>
+                  </p:par>
+                  <p:par>
+                    <p:cTn id="48" fill="hold">
+                      <p:stCondLst>
+                        <p:cond delay="indefinite"/>
+                      </p:stCondLst>
+                      <p:childTnLst>
+                        <p:par>
+                          <p:cTn id="49" fill="hold">
+                            <p:stCondLst>
+                              <p:cond delay="0"/>
+                            </p:stCondLst>
+                            <p:childTnLst>
                               <p:par>
-                                <p:cTn id="32" presetID="10" presetClass="entr" presetSubtype="0" fill="hold" nodeType="withEffect">
+                                <p:cTn id="50" presetID="10" presetClass="entr" presetSubtype="0" fill="hold" nodeType="clickEffect">
                                   <p:stCondLst>
                                     <p:cond delay="0"/>
                                   </p:stCondLst>
                                   <p:childTnLst>
                                     <p:set>
                                       <p:cBhvr>
-                                        <p:cTn id="33" dur="1" fill="hold">
+                                        <p:cTn id="51" dur="1" fill="hold">
                                           <p:stCondLst>
                                             <p:cond delay="0"/>
                                           </p:stCondLst>
@@ -33058,7 +33571,7 @@
                                     </p:set>
                                     <p:animEffect transition="in" filter="fade">
                                       <p:cBhvr>
-                                        <p:cTn id="34" dur="400"/>
+                                        <p:cTn id="52" dur="400"/>
                                         <p:tgtEl>
                                           <p:spTgt spid="53"/>
                                         </p:tgtEl>
@@ -33067,15 +33580,33 @@
                                   </p:childTnLst>
                                 </p:cTn>
                               </p:par>
+                            </p:childTnLst>
+                          </p:cTn>
+                        </p:par>
+                      </p:childTnLst>
+                    </p:cTn>
+                  </p:par>
+                  <p:par>
+                    <p:cTn id="53" fill="hold">
+                      <p:stCondLst>
+                        <p:cond delay="indefinite"/>
+                      </p:stCondLst>
+                      <p:childTnLst>
+                        <p:par>
+                          <p:cTn id="54" fill="hold">
+                            <p:stCondLst>
+                              <p:cond delay="0"/>
+                            </p:stCondLst>
+                            <p:childTnLst>
                               <p:par>
-                                <p:cTn id="35" presetID="10" presetClass="entr" presetSubtype="0" fill="hold" nodeType="withEffect">
+                                <p:cTn id="55" presetID="10" presetClass="entr" presetSubtype="0" fill="hold" nodeType="clickEffect">
                                   <p:stCondLst>
                                     <p:cond delay="0"/>
                                   </p:stCondLst>
                                   <p:childTnLst>
                                     <p:set>
                                       <p:cBhvr>
-                                        <p:cTn id="36" dur="1" fill="hold">
+                                        <p:cTn id="56" dur="1" fill="hold">
                                           <p:stCondLst>
                                             <p:cond delay="0"/>
                                           </p:stCondLst>
@@ -33093,7 +33624,7 @@
                                     </p:set>
                                     <p:animEffect transition="in" filter="fade">
                                       <p:cBhvr>
-                                        <p:cTn id="37" dur="400"/>
+                                        <p:cTn id="57" dur="400"/>
                                         <p:tgtEl>
                                           <p:spTgt spid="57"/>
                                         </p:tgtEl>
@@ -33102,15 +33633,33 @@
                                   </p:childTnLst>
                                 </p:cTn>
                               </p:par>
+                            </p:childTnLst>
+                          </p:cTn>
+                        </p:par>
+                      </p:childTnLst>
+                    </p:cTn>
+                  </p:par>
+                  <p:par>
+                    <p:cTn id="58" fill="hold">
+                      <p:stCondLst>
+                        <p:cond delay="indefinite"/>
+                      </p:stCondLst>
+                      <p:childTnLst>
+                        <p:par>
+                          <p:cTn id="59" fill="hold">
+                            <p:stCondLst>
+                              <p:cond delay="0"/>
+                            </p:stCondLst>
+                            <p:childTnLst>
                               <p:par>
-                                <p:cTn id="38" presetID="10" presetClass="entr" presetSubtype="0" fill="hold" nodeType="withEffect">
+                                <p:cTn id="60" presetID="10" presetClass="entr" presetSubtype="0" fill="hold" nodeType="clickEffect">
                                   <p:stCondLst>
                                     <p:cond delay="0"/>
                                   </p:stCondLst>
                                   <p:childTnLst>
                                     <p:set>
                                       <p:cBhvr>
-                                        <p:cTn id="39" dur="1" fill="hold">
+                                        <p:cTn id="61" dur="1" fill="hold">
                                           <p:stCondLst>
                                             <p:cond delay="0"/>
                                           </p:stCondLst>
@@ -33128,7 +33677,7 @@
                                     </p:set>
                                     <p:animEffect transition="in" filter="fade">
                                       <p:cBhvr>
-                                        <p:cTn id="40" dur="400"/>
+                                        <p:cTn id="62" dur="400"/>
                                         <p:tgtEl>
                                           <p:spTgt spid="61"/>
                                         </p:tgtEl>
@@ -33137,15 +33686,33 @@
                                   </p:childTnLst>
                                 </p:cTn>
                               </p:par>
+                            </p:childTnLst>
+                          </p:cTn>
+                        </p:par>
+                      </p:childTnLst>
+                    </p:cTn>
+                  </p:par>
+                  <p:par>
+                    <p:cTn id="63" fill="hold">
+                      <p:stCondLst>
+                        <p:cond delay="indefinite"/>
+                      </p:stCondLst>
+                      <p:childTnLst>
+                        <p:par>
+                          <p:cTn id="64" fill="hold">
+                            <p:stCondLst>
+                              <p:cond delay="0"/>
+                            </p:stCondLst>
+                            <p:childTnLst>
                               <p:par>
-                                <p:cTn id="41" presetID="10" presetClass="entr" presetSubtype="0" fill="hold" nodeType="withEffect">
+                                <p:cTn id="65" presetID="10" presetClass="entr" presetSubtype="0" fill="hold" nodeType="clickEffect">
                                   <p:stCondLst>
                                     <p:cond delay="0"/>
                                   </p:stCondLst>
                                   <p:childTnLst>
                                     <p:set>
                                       <p:cBhvr>
-                                        <p:cTn id="42" dur="1" fill="hold">
+                                        <p:cTn id="66" dur="1" fill="hold">
                                           <p:stCondLst>
                                             <p:cond delay="0"/>
                                           </p:stCondLst>
@@ -33163,7 +33730,7 @@
                                     </p:set>
                                     <p:animEffect transition="in" filter="fade">
                                       <p:cBhvr>
-                                        <p:cTn id="43" dur="400"/>
+                                        <p:cTn id="67" dur="400"/>
                                         <p:tgtEl>
                                           <p:spTgt spid="62"/>
                                         </p:tgtEl>
@@ -33173,14 +33740,14 @@
                                 </p:cTn>
                               </p:par>
                               <p:par>
-                                <p:cTn id="44" presetID="10" presetClass="entr" presetSubtype="0" fill="hold" nodeType="withEffect">
+                                <p:cTn id="68" presetID="10" presetClass="entr" presetSubtype="0" fill="hold" nodeType="withEffect">
                                   <p:stCondLst>
                                     <p:cond delay="0"/>
                                   </p:stCondLst>
                                   <p:childTnLst>
                                     <p:set>
                                       <p:cBhvr>
-                                        <p:cTn id="45" dur="1" fill="hold">
+                                        <p:cTn id="69" dur="1" fill="hold">
                                           <p:stCondLst>
                                             <p:cond delay="0"/>
                                           </p:stCondLst>
@@ -33198,7 +33765,7 @@
                                     </p:set>
                                     <p:animEffect transition="in" filter="fade">
                                       <p:cBhvr>
-                                        <p:cTn id="46" dur="400"/>
+                                        <p:cTn id="70" dur="400"/>
                                         <p:tgtEl>
                                           <p:spTgt spid="63"/>
                                         </p:tgtEl>
@@ -35866,6 +36433,9 @@
           </a:p>
           <a:p>
             <a:pPr marL="152400" indent="-152400">
+              <a:spcBef>
+                <a:spcPts val="500"/>
+              </a:spcBef>
               <a:spcAft>
                 <a:spcPts val="200"/>
               </a:spcAft>
@@ -37628,6 +38198,9 @@
           </a:p>
           <a:p>
             <a:pPr marL="152400" indent="-152400">
+              <a:spcBef>
+                <a:spcPts val="500"/>
+              </a:spcBef>
               <a:spcAft>
                 <a:spcPts val="200"/>
               </a:spcAft>
@@ -38942,6 +39515,9 @@
           </a:p>
           <a:p>
             <a:pPr marL="152400" indent="-152400">
+              <a:spcBef>
+                <a:spcPts val="500"/>
+              </a:spcBef>
               <a:spcAft>
                 <a:spcPts val="200"/>
               </a:spcAft>

</xml_diff>